<commit_message>
Add power point presentation
</commit_message>
<xml_diff>
--- a/PresentationAndMembers.pptx
+++ b/PresentationAndMembers.pptx
@@ -10536,13 +10536,13 @@
           <a:lstStyle/>
           <a:p>
             <a:r>
-              <a:rPr lang="en-US" sz="6100" b="1"/>
-              <a:t>⛓️ Blockchain Escrow System</a:t>
+              <a:rPr lang="en-US" sz="4400" b="1" dirty="0"/>
+              <a:t>⛓️ Decentralized Freelance Payment System with Smart Contract Escrow</a:t>
             </a:r>
             <a:br>
-              <a:rPr lang="en-US" sz="6100" b="1"/>
+              <a:rPr lang="en-US" sz="6100" b="1" dirty="0"/>
             </a:br>
-            <a:endParaRPr lang="en-US" sz="6100" b="1"/>
+            <a:endParaRPr lang="en-US" sz="6100" b="1" dirty="0"/>
           </a:p>
         </p:txBody>
       </p:sp>

</xml_diff>